<commit_message>
Update project presentation slides for AeroQuest
</commit_message>
<xml_diff>
--- a/AeroQuest_Presentation.pptx
+++ b/AeroQuest_Presentation.pptx
@@ -3152,7 +3152,7 @@
               </a:defRPr>
             </a:pPr>
             <a:r>
-              <a:t>Advanced Full-Stack Dashboard for Global Atmospheric Analytics</a:t>
+              <a:t>Advanced Full-Stack Dashboard for Global Air Quality &amp; Weather Analytics</a:t>
             </a:r>
           </a:p>
         </p:txBody>
@@ -3214,7 +3214,7 @@
               </a:defRPr>
             </a:pPr>
             <a:r>
-              <a:t>9. Conclusion &amp; Next Steps</a:t>
+              <a:t>9. Conclusion &amp; Project Deliverables</a:t>
             </a:r>
           </a:p>
         </p:txBody>
@@ -3253,7 +3253,7 @@
               </a:defRPr>
             </a:pPr>
             <a:r>
-              <a:t>•  IoT Integrations: Supporting localized smart air-purifier and home monitor APIs.</a:t>
+              <a:t>•  Success: Successfully resolved key API redirects, unit scaling issues, and database persistence.</a:t>
             </a:r>
           </a:p>
           <a:p>
@@ -3269,7 +3269,7 @@
               </a:defRPr>
             </a:pPr>
             <a:r>
-              <a:t>•  Push Notifications: Alerting sensitive groups on sudden PM2.5 spikes.</a:t>
+              <a:t>•  Cloud Deployments: Deployed and live on Render at https://aeroquest-11v1.onrender.com.</a:t>
             </a:r>
           </a:p>
           <a:p>
@@ -3285,7 +3285,7 @@
               </a:defRPr>
             </a:pPr>
             <a:r>
-              <a:t>•  AI Forecasting: Machine learning layers to predict AQI spikes based on wind forecasts.</a:t>
+              <a:t>•  IoT Roadmap: Interfacing localized indoor smart-purifier metrics with regional warnings.</a:t>
             </a:r>
           </a:p>
           <a:p>
@@ -3301,7 +3301,7 @@
               </a:defRPr>
             </a:pPr>
             <a:r>
-              <a:t>•  Deployments: Containerizing the Flask server using Docker for cloud hosting.</a:t>
+              <a:t>•  AI Forecasting: Using historical datasets to predict next-day AQI trends based on wind directions.</a:t>
             </a:r>
           </a:p>
         </p:txBody>
@@ -3363,7 +3363,7 @@
               </a:defRPr>
             </a:pPr>
             <a:r>
-              <a:t>1. Project Vision &amp; Goals</a:t>
+              <a:t>1. Project Vision &amp; Core Features</a:t>
             </a:r>
           </a:p>
         </p:txBody>
@@ -3418,7 +3418,7 @@
               </a:defRPr>
             </a:pPr>
             <a:r>
-              <a:t>•  Provide an out-of-the-box system that requires NO configuration or complex API key registrations.</a:t>
+              <a:t>•  Fuse real-time meteorology (wind, humidity, temp) with pollutant metrics.</a:t>
             </a:r>
           </a:p>
           <a:p>
@@ -3434,7 +3434,23 @@
               </a:defRPr>
             </a:pPr>
             <a:r>
-              <a:t>•  Fuse real-time meteorology (temperature, wind, humidity) with chemical pollutants concentrations.</a:t>
+              <a:t>•  Automate public health recommendations tailored for active lifestyles.</a:t>
+            </a:r>
+          </a:p>
+          <a:p>
+            <a:pPr>
+              <a:spcAft>
+                <a:spcPts val="1600"/>
+              </a:spcAft>
+              <a:defRPr sz="2000">
+                <a:solidFill>
+                  <a:srgbClr val="F3F4F6"/>
+                </a:solidFill>
+                <a:latin typeface="Inter"/>
+              </a:defRPr>
+            </a:pPr>
+            <a:r>
+              <a:t>•  Provide an out-of-the-box system that requires no complex configurations.</a:t>
             </a:r>
           </a:p>
           <a:p>
@@ -3567,7 +3583,7 @@
               </a:defRPr>
             </a:pPr>
             <a:r>
-              <a:t>•  Database Caching: SQLite3 (built-in relational database).</a:t>
+              <a:t>•  Database Caching: SQLite3 for favorites and search logs.</a:t>
             </a:r>
           </a:p>
           <a:p>
@@ -3599,7 +3615,7 @@
               </a:defRPr>
             </a:pPr>
             <a:r>
-              <a:t>•  Visualization: Chart.js (Interactive forecasting curves).</a:t>
+              <a:t>•  Ground Station Feeds: WAQI API (Real-time air pollution indexes).</a:t>
             </a:r>
           </a:p>
           <a:p>
@@ -3615,7 +3631,7 @@
               </a:defRPr>
             </a:pPr>
             <a:r>
-              <a:t>•  Mapping: Leaflet.js (Interactive GIS maps with custom pulsing marker indicators).</a:t>
+              <a:t>•  Visualization: Chart.js (Historical trends) and Leaflet.js (GIS Mapping).</a:t>
             </a:r>
           </a:p>
         </p:txBody>
@@ -3677,7 +3693,7 @@
               </a:defRPr>
             </a:pPr>
             <a:r>
-              <a:t>3. Python Server Logic (app.py)</a:t>
+              <a:t>3. WAQI API Redirect Fallback Logic</a:t>
             </a:r>
           </a:p>
         </p:txBody>
@@ -3716,7 +3732,7 @@
               </a:defRPr>
             </a:pPr>
             <a:r>
-              <a:t>•  Route Proxying: Exposes custom endpoints like /api/air-quality to fetch raw payloads safely.</a:t>
+              <a:t>•  The Challenge: WAQI 'demo' token geolocated requests force-redirect to Shanghai.</a:t>
             </a:r>
           </a:p>
           <a:p>
@@ -3732,7 +3748,7 @@
               </a:defRPr>
             </a:pPr>
             <a:r>
-              <a:t>•  CORS Mitigation: Prevents cross-origin file loading errors by proxying browser calls on the server.</a:t>
+              <a:t>•  The Solution: Implemented latitude/longitude coordinate distance verification checks.</a:t>
             </a:r>
           </a:p>
           <a:p>
@@ -3748,7 +3764,7 @@
               </a:defRPr>
             </a:pPr>
             <a:r>
-              <a:t>•  Error Handling: Traps exceptions during API fetches and returns user-friendly JSON payloads.</a:t>
+              <a:t>•  The Logic: If returned station coordinates differ from queried coordinates by &gt; 2.0 degrees, the redirect is flagged as hijack.</a:t>
             </a:r>
           </a:p>
           <a:p>
@@ -3764,7 +3780,23 @@
               </a:defRPr>
             </a:pPr>
             <a:r>
-              <a:t>•  Tuned Performance: Configured with debug=False for solid production execution in isolated sessions.</a:t>
+              <a:t>•  Fallback Path: Backend discards fake station data and falls back to localized Open-Meteo forecasts.</a:t>
+            </a:r>
+          </a:p>
+          <a:p>
+            <a:pPr>
+              <a:spcAft>
+                <a:spcPts val="1600"/>
+              </a:spcAft>
+              <a:defRPr sz="2000">
+                <a:solidFill>
+                  <a:srgbClr val="F3F4F6"/>
+                </a:solidFill>
+                <a:latin typeface="Inter"/>
+              </a:defRPr>
+            </a:pPr>
+            <a:r>
+              <a:t>•  Token Settings: User input widget in sidebar footer saves custom WAQI token in localStorage.</a:t>
             </a:r>
           </a:p>
         </p:txBody>
@@ -3975,7 +4007,7 @@
               </a:defRPr>
             </a:pPr>
             <a:r>
-              <a:t>5. UI/UX &amp; Glassmorphism Design</a:t>
+              <a:t>5. WHO Exceedance Alert System</a:t>
             </a:r>
           </a:p>
         </p:txBody>
@@ -4014,7 +4046,7 @@
               </a:defRPr>
             </a:pPr>
             <a:r>
-              <a:t>•  Modern Layout: Dark-mode by default with optional high-contrast Light Theme toggle.</a:t>
+              <a:t>•  Analytical Engine: Calculates active health warnings when pollutants exceed WHO 24h safety standards.</a:t>
             </a:r>
           </a:p>
           <a:p>
@@ -4030,7 +4062,7 @@
               </a:defRPr>
             </a:pPr>
             <a:r>
-              <a:t>•  Glassmorphism: Utilizes backdrop-filter: blur() with subtle semitransparent borders.</a:t>
+              <a:t>•  Unit Conversion: Divides Carbon Monoxide (CO) concentration by 1000 to scale from micrograms to milligrams, preventing false warnings.</a:t>
             </a:r>
           </a:p>
           <a:p>
@@ -4046,7 +4078,7 @@
               </a:defRPr>
             </a:pPr>
             <a:r>
-              <a:t>•  Dynamic Colors: Modifies CSS variables to color-match card glows to the active city's AQI severity.</a:t>
+              <a:t>•  Ratio Math: Multiplier = Concentration / WHO safe limit.</a:t>
             </a:r>
           </a:p>
           <a:p>
@@ -4062,7 +4094,7 @@
               </a:defRPr>
             </a:pPr>
             <a:r>
-              <a:t>•  Fluid Responsiveness: Optimized layout grids for mobile, tablet, and widescreen monitors.</a:t>
+              <a:t>•  Dynamic UI: Highlights exceedance multipliers (e.g. 'PM2.5 is 2.4x above WHO safe limit').</a:t>
             </a:r>
           </a:p>
         </p:txBody>
@@ -4124,7 +4156,7 @@
               </a:defRPr>
             </a:pPr>
             <a:r>
-              <a:t>6. GIS Leaflet Mapping Engine</a:t>
+              <a:t>6. Weather-AQI Correlation Engine</a:t>
             </a:r>
           </a:p>
         </p:txBody>
@@ -4163,7 +4195,7 @@
               </a:defRPr>
             </a:pPr>
             <a:r>
-              <a:t>•  Renders interactive maps using lightweight, CDN-hosted Leaflet.js.</a:t>
+              <a:t>•  Meteorological Rules: Combines wind speed, relative humidity, and temperatures.</a:t>
             </a:r>
           </a:p>
           <a:p>
@@ -4179,7 +4211,7 @@
               </a:defRPr>
             </a:pPr>
             <a:r>
-              <a:t>•  Features CARTO Voyager (light) and Dark Matter (dark) custom tile styling.</a:t>
+              <a:t>•  Stagnation Alerts: Warns users when wind speed &lt; 10 km/h and humidity &gt; 80% that local atmospheric conditions are trapping particulates.</a:t>
             </a:r>
           </a:p>
           <a:p>
@@ -4195,7 +4227,7 @@
               </a:defRPr>
             </a:pPr>
             <a:r>
-              <a:t>•  Applies custom HTML divIcons that pulse with colors mapped to US AQI guidelines.</a:t>
+              <a:t>•  Dispersion Insights: Explains how high winds (&gt; 15 km/h) disperse chemical pollutants.</a:t>
             </a:r>
           </a:p>
           <a:p>
@@ -4211,7 +4243,7 @@
               </a:defRPr>
             </a:pPr>
             <a:r>
-              <a:t>•  Invalidates sizes on layout shifts to prevent grey layout rendering bugs.</a:t>
+              <a:t>•  Aesthetic Cards: Dynamic insights card rendered seamlessly next to the gauge.</a:t>
             </a:r>
           </a:p>
         </p:txBody>
@@ -4273,7 +4305,7 @@
               </a:defRPr>
             </a:pPr>
             <a:r>
-              <a:t>7. Chart.js Forecast &amp; Analytics</a:t>
+              <a:t>7. Cleanest City Leaderboard</a:t>
             </a:r>
           </a:p>
         </p:txBody>
@@ -4312,7 +4344,7 @@
               </a:defRPr>
             </a:pPr>
             <a:r>
-              <a:t>•  Draws 7-day hourly analytics curves using modern HTML5 Canvas widgets.</a:t>
+              <a:t>•  Dynamic Sorting: Compiles favorites list in real-time, fetching active air quality readings.</a:t>
             </a:r>
           </a:p>
           <a:p>
@@ -4328,7 +4360,7 @@
               </a:defRPr>
             </a:pPr>
             <a:r>
-              <a:t>•  Filters: Interactive filters for PM2.5, PM10, Ozone, and Nitrogen Dioxide.</a:t>
+              <a:t>•  Sort Order: Automatically ranks cities ascending (cleanest to most polluted).</a:t>
             </a:r>
           </a:p>
           <a:p>
@@ -4344,7 +4376,7 @@
               </a:defRPr>
             </a:pPr>
             <a:r>
-              <a:t>•  Verdicts: Computes and displays peak values, lowest values, and average conditions.</a:t>
+              <a:t>•  Premium Visuals: Uses customized ranking badges, layout transitions, and green-to-red severity indicators.</a:t>
             </a:r>
           </a:p>
           <a:p>
@@ -4360,7 +4392,7 @@
               </a:defRPr>
             </a:pPr>
             <a:r>
-              <a:t>•  Dual-City Overlay: Graphs comparison curves side-by-side on a single comparison grid.</a:t>
+              <a:t>•  Asynchronous Grid: Automatically updates as favorites are bookmarked or removed.</a:t>
             </a:r>
           </a:p>
         </p:txBody>
@@ -4422,7 +4454,7 @@
               </a:defRPr>
             </a:pPr>
             <a:r>
-              <a:t>8. Dual-City Comparison Engine</a:t>
+              <a:t>8. UI/UX &amp; GIS Mapping Engine</a:t>
             </a:r>
           </a:p>
         </p:txBody>
@@ -4461,7 +4493,7 @@
               </a:defRPr>
             </a:pPr>
             <a:r>
-              <a:t>•  Allows users to select any two cities dynamically (City A vs City B).</a:t>
+              <a:t>•  Interactive Mapping: Custom Leaflet.js canvases using dark-matter/voyager tile schemes.</a:t>
             </a:r>
           </a:p>
           <a:p>
@@ -4477,7 +4509,7 @@
               </a:defRPr>
             </a:pPr>
             <a:r>
-              <a:t>•  Calculates clean air percentage verdicts: e.g. 'City A is 25% cleaner than City B'.</a:t>
+              <a:t>•  Pulsing HTML divIcons: Color-coded map indicators matching the US AQI severity scale.</a:t>
             </a:r>
           </a:p>
           <a:p>
@@ -4493,7 +4525,7 @@
               </a:defRPr>
             </a:pPr>
             <a:r>
-              <a:t>•  Extracts comparative metrics (CO, SO2, O3, Dust) side-by-side.</a:t>
+              <a:t>•  Dual-City Compare: Parallel Chart.js forecast curves comparing two cities side-by-side.</a:t>
             </a:r>
           </a:p>
           <a:p>
@@ -4509,7 +4541,7 @@
               </a:defRPr>
             </a:pPr>
             <a:r>
-              <a:t>•  Fuses both datasets and renders dual-curves to compare forecasts at a glance.</a:t>
+              <a:t>•  Responsive Grids: Fluid glassmorphism layouts with backdropped blurring effects.</a:t>
             </a:r>
           </a:p>
         </p:txBody>

</xml_diff>

<commit_message>
Generate final AeroQuest PowerPoint presentation with 5 students and PYTHON highlights
</commit_message>
<xml_diff>
--- a/AeroQuest_Presentation.pptx
+++ b/AeroQuest_Presentation.pptx
@@ -3113,8 +3113,8 @@
         </p:nvSpPr>
         <p:spPr>
           <a:xfrm>
-            <a:off x="1371600" y="2011680"/>
-            <a:ext cx="9445752" cy="2743200"/>
+            <a:off x="914400" y="1371600"/>
+            <a:ext cx="10360152" cy="4114800"/>
           </a:xfrm>
           <a:prstGeom prst="rect">
             <a:avLst/>
@@ -3142,9 +3142,9 @@
           <a:p>
             <a:pPr algn="ctr">
               <a:spcBef>
-                <a:spcPts val="2000"/>
+                <a:spcPts val="1500"/>
               </a:spcBef>
-              <a:defRPr sz="2200">
+              <a:defRPr sz="2000">
                 <a:solidFill>
                   <a:srgbClr val="10B981"/>
                 </a:solidFill>
@@ -3152,7 +3152,71 @@
               </a:defRPr>
             </a:pPr>
             <a:r>
-              <a:t>Advanced Full-Stack Dashboard for Global Air Quality &amp; Weather Analytics</a:t>
+              <a:t>Advanced PYTHON &amp; Flask Web Application for Global Air Quality &amp; Weather Analytics</a:t>
+            </a:r>
+          </a:p>
+          <a:p>
+            <a:pPr algn="ctr">
+              <a:spcBef>
+                <a:spcPts val="3000"/>
+              </a:spcBef>
+              <a:defRPr sz="1400">
+                <a:solidFill>
+                  <a:srgbClr val="9CA3AF"/>
+                </a:solidFill>
+                <a:latin typeface="Inter"/>
+              </a:defRPr>
+            </a:pPr>
+            <a:r>
+              <a:t>Submitted by:</a:t>
+            </a:r>
+          </a:p>
+          <a:p>
+            <a:pPr algn="ctr">
+              <a:spcBef>
+                <a:spcPts val="500"/>
+              </a:spcBef>
+              <a:defRPr sz="1400" b="1">
+                <a:solidFill>
+                  <a:srgbClr val="F3F4F6"/>
+                </a:solidFill>
+                <a:latin typeface="Inter"/>
+              </a:defRPr>
+            </a:pPr>
+            <a:r>
+              <a:t>SHIVARAJ (25SUUBECS1323) | SHIVAKUMAR KH (25SUUBECS1319)</a:t>
+            </a:r>
+          </a:p>
+          <a:p>
+            <a:pPr algn="ctr">
+              <a:spcBef>
+                <a:spcPts val="500"/>
+              </a:spcBef>
+              <a:defRPr sz="1400" b="1">
+                <a:solidFill>
+                  <a:srgbClr val="F3F4F6"/>
+                </a:solidFill>
+                <a:latin typeface="Inter"/>
+              </a:defRPr>
+            </a:pPr>
+            <a:r>
+              <a:t>SHREYAS AG (25SUUBECS1351) | SHREYAS HS (25SUUBECS1354)</a:t>
+            </a:r>
+          </a:p>
+          <a:p>
+            <a:pPr algn="ctr">
+              <a:spcBef>
+                <a:spcPts val="500"/>
+              </a:spcBef>
+              <a:defRPr sz="1400" b="1">
+                <a:solidFill>
+                  <a:srgbClr val="F3F4F6"/>
+                </a:solidFill>
+                <a:latin typeface="Inter"/>
+              </a:defRPr>
+            </a:pPr>
+            <a:r>
+              <a:t>SHREYAS SUVIGYA (25SUUBECS1361)</a:t>
             </a:r>
           </a:p>
         </p:txBody>
@@ -3567,7 +3631,23 @@
               </a:defRPr>
             </a:pPr>
             <a:r>
-              <a:t>•  Backend: Python 3.13 + Flask framework.</a:t>
+              <a:t>•  Core Language: PYTHON 3.13.</a:t>
+            </a:r>
+          </a:p>
+          <a:p>
+            <a:pPr>
+              <a:spcAft>
+                <a:spcPts val="1600"/>
+              </a:spcAft>
+              <a:defRPr sz="2000">
+                <a:solidFill>
+                  <a:srgbClr val="F3F4F6"/>
+                </a:solidFill>
+                <a:latin typeface="Inter"/>
+              </a:defRPr>
+            </a:pPr>
+            <a:r>
+              <a:t>•  Backend Controller: Flask microframework.</a:t>
             </a:r>
           </a:p>
           <a:p>

</xml_diff>

<commit_message>
Add Thank You slide with Python quote to AeroQuest PowerPoint presentation
</commit_message>
<xml_diff>
--- a/AeroQuest_Presentation.pptx
+++ b/AeroQuest_Presentation.pptx
@@ -15,6 +15,7 @@
     <p:sldId id="263" r:id="rId14"/>
     <p:sldId id="264" r:id="rId15"/>
     <p:sldId id="265" r:id="rId16"/>
+    <p:sldId id="266" r:id="rId17"/>
   </p:sldIdLst>
   <p:sldSz cx="12191695" cy="6858000" type="screen4x3"/>
   <p:notesSz cx="6858000" cy="9144000"/>
@@ -3366,6 +3367,100 @@
             </a:pPr>
             <a:r>
               <a:t>•  AI Forecasting: Using historical datasets to predict next-day AQI trends based on wind directions.</a:t>
+            </a:r>
+          </a:p>
+        </p:txBody>
+      </p:sp>
+    </p:spTree>
+  </p:cSld>
+  <p:clrMapOvr>
+    <a:masterClrMapping/>
+  </p:clrMapOvr>
+</p:sld>
+</file>
+
+<file path=ppt/slides/slide11.xml><?xml version="1.0" encoding="utf-8"?>
+<p:sld xmlns:a="http://schemas.openxmlformats.org/drawingml/2006/main" xmlns:p="http://schemas.openxmlformats.org/presentationml/2006/main" xmlns:r="http://schemas.openxmlformats.org/officeDocument/2006/relationships">
+  <p:cSld>
+    <p:bg>
+      <p:bgPr>
+        <a:solidFill>
+          <a:srgbClr val="090D16"/>
+        </a:solidFill>
+        <a:effectLst/>
+      </p:bgPr>
+    </p:bg>
+    <p:spTree>
+      <p:nvGrpSpPr>
+        <p:cNvPr id="1" name=""/>
+        <p:cNvGrpSpPr/>
+        <p:nvPr/>
+      </p:nvGrpSpPr>
+      <p:grpSpPr/>
+      <p:sp>
+        <p:nvSpPr>
+          <p:cNvPr id="2" name="TextBox 1"/>
+          <p:cNvSpPr txBox="1"/>
+          <p:nvPr/>
+        </p:nvSpPr>
+        <p:spPr>
+          <a:xfrm>
+            <a:off x="1371600" y="1828800"/>
+            <a:ext cx="9445752" cy="3657600"/>
+          </a:xfrm>
+          <a:prstGeom prst="rect">
+            <a:avLst/>
+          </a:prstGeom>
+          <a:noFill/>
+        </p:spPr>
+        <p:txBody>
+          <a:bodyPr wrap="square">
+            <a:spAutoFit/>
+          </a:bodyPr>
+          <a:lstStyle/>
+          <a:p>
+            <a:pPr algn="ctr">
+              <a:defRPr sz="6000" b="1">
+                <a:solidFill>
+                  <a:srgbClr val="10B981"/>
+                </a:solidFill>
+                <a:latin typeface="Outfit"/>
+              </a:defRPr>
+            </a:pPr>
+            <a:r>
+              <a:t>THANK YOU</a:t>
+            </a:r>
+          </a:p>
+          <a:p>
+            <a:pPr algn="ctr">
+              <a:spcBef>
+                <a:spcPts val="3000"/>
+              </a:spcBef>
+              <a:defRPr sz="2000" i="1">
+                <a:solidFill>
+                  <a:srgbClr val="F3F4F6"/>
+                </a:solidFill>
+                <a:latin typeface="Inter"/>
+              </a:defRPr>
+            </a:pPr>
+            <a:r>
+              <a:t>"The joy of coding Python should be in seeing short, clean, readable classes that express a lot of action in a small amount of clear code."</a:t>
+            </a:r>
+          </a:p>
+          <a:p>
+            <a:pPr algn="ctr">
+              <a:spcBef>
+                <a:spcPts val="1000"/>
+              </a:spcBef>
+              <a:defRPr sz="1600">
+                <a:solidFill>
+                  <a:srgbClr val="9CA3AF"/>
+                </a:solidFill>
+                <a:latin typeface="Inter"/>
+              </a:defRPr>
+            </a:pPr>
+            <a:r>
+              <a:t>— Guido van Rossum (Creator of Python)</a:t>
             </a:r>
           </a:p>
         </p:txBody>

</xml_diff>